<commit_message>
added antecedent and consequent filtration, added supp, conf and lift sorts, added button for easy transition to another page for loading data, started adding the quartile table
</commit_message>
<xml_diff>
--- a/docs/Eliseev EV.pptx
+++ b/docs/Eliseev EV.pptx
@@ -276,7 +276,7 @@
           <a:p>
             <a:fld id="{6C1C013D-C6A7-4DB5-A4FD-238D75ACE54A}" type="datetimeFigureOut">
               <a:rPr lang="ru-RU" smtClean="0"/>
-              <a:t>20.05.2024</a:t>
+              <a:t>21.05.2024</a:t>
             </a:fld>
             <a:endParaRPr lang="ru-RU"/>
           </a:p>
@@ -846,7 +846,7 @@
           <a:p>
             <a:fld id="{9CB2C4F5-5D00-4DC3-8376-C6BD28F02CAB}" type="datetimeFigureOut">
               <a:rPr lang="ru-RU" smtClean="0"/>
-              <a:t>20.05.2024</a:t>
+              <a:t>21.05.2024</a:t>
             </a:fld>
             <a:endParaRPr lang="ru-RU"/>
           </a:p>
@@ -2791,7 +2791,7 @@
           <a:p>
             <a:fld id="{AB6DC8CD-6662-424D-AE90-09DAABF92620}" type="datetime1">
               <a:rPr lang="ru-RU" smtClean="0"/>
-              <a:t>20.05.2024</a:t>
+              <a:t>21.05.2024</a:t>
             </a:fld>
             <a:endParaRPr lang="ru-RU"/>
           </a:p>
@@ -2992,7 +2992,7 @@
           <a:p>
             <a:fld id="{FC10AB9E-9F86-4008-83C2-D060ECF160DE}" type="datetime1">
               <a:rPr lang="ru-RU" smtClean="0"/>
-              <a:t>20.05.2024</a:t>
+              <a:t>21.05.2024</a:t>
             </a:fld>
             <a:endParaRPr lang="ru-RU"/>
           </a:p>
@@ -3203,7 +3203,7 @@
           <a:p>
             <a:fld id="{CE90D746-DE99-49E7-BFDC-F6203EEEF690}" type="datetime1">
               <a:rPr lang="ru-RU" smtClean="0"/>
-              <a:t>20.05.2024</a:t>
+              <a:t>21.05.2024</a:t>
             </a:fld>
             <a:endParaRPr lang="ru-RU"/>
           </a:p>
@@ -3404,7 +3404,7 @@
           <a:p>
             <a:fld id="{D7E82507-A74A-4BF9-AA7C-C9B06358C86A}" type="datetime1">
               <a:rPr lang="ru-RU" smtClean="0"/>
-              <a:t>20.05.2024</a:t>
+              <a:t>21.05.2024</a:t>
             </a:fld>
             <a:endParaRPr lang="ru-RU"/>
           </a:p>
@@ -3682,7 +3682,7 @@
           <a:p>
             <a:fld id="{728A183E-E26E-4A33-96BC-7D4DD5899954}" type="datetime1">
               <a:rPr lang="ru-RU" smtClean="0"/>
-              <a:t>20.05.2024</a:t>
+              <a:t>21.05.2024</a:t>
             </a:fld>
             <a:endParaRPr lang="ru-RU"/>
           </a:p>
@@ -3950,7 +3950,7 @@
           <a:p>
             <a:fld id="{7DE59FAF-71FF-4857-A9AC-33A232A7D036}" type="datetime1">
               <a:rPr lang="ru-RU" smtClean="0"/>
-              <a:t>20.05.2024</a:t>
+              <a:t>21.05.2024</a:t>
             </a:fld>
             <a:endParaRPr lang="ru-RU"/>
           </a:p>
@@ -4365,7 +4365,7 @@
           <a:p>
             <a:fld id="{49BFE76A-CA5A-4492-9E51-5062A098B11E}" type="datetime1">
               <a:rPr lang="ru-RU" smtClean="0"/>
-              <a:t>20.05.2024</a:t>
+              <a:t>21.05.2024</a:t>
             </a:fld>
             <a:endParaRPr lang="ru-RU"/>
           </a:p>
@@ -4509,7 +4509,7 @@
           <a:p>
             <a:fld id="{B10BA3AC-209D-4273-8D5F-8B3583970EE6}" type="datetime1">
               <a:rPr lang="ru-RU" smtClean="0"/>
-              <a:t>20.05.2024</a:t>
+              <a:t>21.05.2024</a:t>
             </a:fld>
             <a:endParaRPr lang="ru-RU"/>
           </a:p>
@@ -4944,7 +4944,7 @@
           <a:p>
             <a:fld id="{7ACA74DB-CB7C-44E0-85BB-5DF41B44EDDA}" type="datetime1">
               <a:rPr lang="ru-RU" smtClean="0"/>
-              <a:t>20.05.2024</a:t>
+              <a:t>21.05.2024</a:t>
             </a:fld>
             <a:endParaRPr lang="ru-RU"/>
           </a:p>
@@ -5235,7 +5235,7 @@
           <a:p>
             <a:fld id="{5505F3AB-125B-44BD-91E0-D0D5DD24AA45}" type="datetime1">
               <a:rPr lang="ru-RU" smtClean="0"/>
-              <a:t>20.05.2024</a:t>
+              <a:t>21.05.2024</a:t>
             </a:fld>
             <a:endParaRPr lang="ru-RU"/>
           </a:p>
@@ -5479,7 +5479,7 @@
           <a:p>
             <a:fld id="{41B538B3-6C19-4897-BE7C-A7C7284CDE90}" type="datetime1">
               <a:rPr lang="ru-RU" smtClean="0"/>
-              <a:t>20.05.2024</a:t>
+              <a:t>21.05.2024</a:t>
             </a:fld>
             <a:endParaRPr lang="ru-RU"/>
           </a:p>
@@ -9034,12 +9034,74 @@
           </a:p>
         </p:txBody>
       </p:sp>
+      <p:sp>
+        <p:nvSpPr>
+          <p:cNvPr id="4" name="Footer Placeholder 3">
+            <a:extLst>
+              <a:ext uri="{FF2B5EF4-FFF2-40B4-BE49-F238E27FC236}">
+                <a16:creationId xmlns:a16="http://schemas.microsoft.com/office/drawing/2014/main" id="{D07AB4D5-EBAB-A843-97C2-17C51A169A12}"/>
+              </a:ext>
+            </a:extLst>
+          </p:cNvPr>
+          <p:cNvSpPr>
+            <a:spLocks noGrp="1"/>
+          </p:cNvSpPr>
+          <p:nvPr>
+            <p:ph type="ftr" sz="quarter" idx="11"/>
+          </p:nvPr>
+        </p:nvSpPr>
+        <p:spPr/>
+        <p:txBody>
+          <a:bodyPr/>
+          <a:lstStyle/>
+          <a:p>
+            <a:r>
+              <a:rPr lang="ru-RU"/>
+              <a:t>Система поиска шаблонов в данных GitHub</a:t>
+            </a:r>
+            <a:endParaRPr lang="ru-RU" dirty="0"/>
+          </a:p>
+        </p:txBody>
+      </p:sp>
+      <p:sp>
+        <p:nvSpPr>
+          <p:cNvPr id="2" name="Slide Number Placeholder 1">
+            <a:extLst>
+              <a:ext uri="{FF2B5EF4-FFF2-40B4-BE49-F238E27FC236}">
+                <a16:creationId xmlns:a16="http://schemas.microsoft.com/office/drawing/2014/main" id="{573D64B6-9EF6-4756-C38C-767F7BCA6823}"/>
+              </a:ext>
+            </a:extLst>
+          </p:cNvPr>
+          <p:cNvSpPr>
+            <a:spLocks noGrp="1"/>
+          </p:cNvSpPr>
+          <p:nvPr>
+            <p:ph type="sldNum" sz="quarter" idx="12"/>
+          </p:nvPr>
+        </p:nvSpPr>
+        <p:spPr/>
+        <p:txBody>
+          <a:bodyPr/>
+          <a:lstStyle/>
+          <a:p>
+            <a:fld id="{7EC09024-2147-4C4E-87D2-FF66EAF91B1A}" type="slidenum">
+              <a:rPr lang="ru-RU" smtClean="0"/>
+              <a:pPr/>
+              <a:t>16</a:t>
+            </a:fld>
+            <a:r>
+              <a:rPr lang="ru-RU" dirty="0"/>
+              <a:t>/21</a:t>
+            </a:r>
+          </a:p>
+        </p:txBody>
+      </p:sp>
       <p:pic>
         <p:nvPicPr>
-          <p:cNvPr id="6" name="Picture 5">
-            <a:extLst>
-              <a:ext uri="{FF2B5EF4-FFF2-40B4-BE49-F238E27FC236}">
-                <a16:creationId xmlns:a16="http://schemas.microsoft.com/office/drawing/2014/main" id="{1B7B6E12-90BB-E584-A2E9-2EFC18F6A082}"/>
+          <p:cNvPr id="7" name="Picture 6">
+            <a:extLst>
+              <a:ext uri="{FF2B5EF4-FFF2-40B4-BE49-F238E27FC236}">
+                <a16:creationId xmlns:a16="http://schemas.microsoft.com/office/drawing/2014/main" id="{18779764-6135-341E-1B35-2EEE9AA47D41}"/>
               </a:ext>
             </a:extLst>
           </p:cNvPr>
@@ -9056,8 +9118,8 @@
         </p:blipFill>
         <p:spPr>
           <a:xfrm>
-            <a:off x="1043104" y="1016297"/>
-            <a:ext cx="10105792" cy="5082795"/>
+            <a:off x="1251237" y="989398"/>
+            <a:ext cx="9689525" cy="4879204"/>
           </a:xfrm>
           <a:prstGeom prst="rect">
             <a:avLst/>
@@ -9069,68 +9131,6 @@
           </a:ln>
         </p:spPr>
       </p:pic>
-      <p:sp>
-        <p:nvSpPr>
-          <p:cNvPr id="4" name="Footer Placeholder 3">
-            <a:extLst>
-              <a:ext uri="{FF2B5EF4-FFF2-40B4-BE49-F238E27FC236}">
-                <a16:creationId xmlns:a16="http://schemas.microsoft.com/office/drawing/2014/main" id="{D07AB4D5-EBAB-A843-97C2-17C51A169A12}"/>
-              </a:ext>
-            </a:extLst>
-          </p:cNvPr>
-          <p:cNvSpPr>
-            <a:spLocks noGrp="1"/>
-          </p:cNvSpPr>
-          <p:nvPr>
-            <p:ph type="ftr" sz="quarter" idx="11"/>
-          </p:nvPr>
-        </p:nvSpPr>
-        <p:spPr/>
-        <p:txBody>
-          <a:bodyPr/>
-          <a:lstStyle/>
-          <a:p>
-            <a:r>
-              <a:rPr lang="ru-RU"/>
-              <a:t>Система поиска шаблонов в данных GitHub</a:t>
-            </a:r>
-            <a:endParaRPr lang="ru-RU" dirty="0"/>
-          </a:p>
-        </p:txBody>
-      </p:sp>
-      <p:sp>
-        <p:nvSpPr>
-          <p:cNvPr id="2" name="Slide Number Placeholder 1">
-            <a:extLst>
-              <a:ext uri="{FF2B5EF4-FFF2-40B4-BE49-F238E27FC236}">
-                <a16:creationId xmlns:a16="http://schemas.microsoft.com/office/drawing/2014/main" id="{573D64B6-9EF6-4756-C38C-767F7BCA6823}"/>
-              </a:ext>
-            </a:extLst>
-          </p:cNvPr>
-          <p:cNvSpPr>
-            <a:spLocks noGrp="1"/>
-          </p:cNvSpPr>
-          <p:nvPr>
-            <p:ph type="sldNum" sz="quarter" idx="12"/>
-          </p:nvPr>
-        </p:nvSpPr>
-        <p:spPr/>
-        <p:txBody>
-          <a:bodyPr/>
-          <a:lstStyle/>
-          <a:p>
-            <a:fld id="{7EC09024-2147-4C4E-87D2-FF66EAF91B1A}" type="slidenum">
-              <a:rPr lang="ru-RU" smtClean="0"/>
-              <a:pPr/>
-              <a:t>16</a:t>
-            </a:fld>
-            <a:r>
-              <a:rPr lang="ru-RU" dirty="0"/>
-              <a:t>/21</a:t>
-            </a:r>
-          </a:p>
-        </p:txBody>
-      </p:sp>
     </p:spTree>
     <p:extLst>
       <p:ext uri="{BB962C8B-B14F-4D97-AF65-F5344CB8AC3E}">

</xml_diff>